<commit_message>
﻿Fix three layout defects in the deck
Two-line slide titles were overlapping the small kicker label above them,
because the title box centred its text vertically and grew upward. Titles now
anchor to the top so a second line grows downward instead.

Slide 4: the closing caption sat on top of the fourth card.
Slide 14: the disclaimer overlapped the last row and crowded the footer.
</commit_message>
<xml_diff>
--- a/Military-Pay-Estimator-Guide.pptx
+++ b/Military-Pay-Estimator-Guide.pptx
@@ -2649,17 +2649,17 @@
         </p:nvSpPr>
         <p:spPr>
           <a:xfrm>
-            <a:off x="640080" y="640080"/>
-            <a:ext cx="10881360" cy="566928"/>
-          </a:xfrm>
-          <a:prstGeom prst="rect">
-            <a:avLst/>
-          </a:prstGeom>
-          <a:noFill/>
-          <a:ln/>
-        </p:spPr>
-        <p:txBody>
-          <a:bodyPr wrap="square" rtlCol="0" anchor="ctr"/>
+            <a:off x="640080" y="658368"/>
+            <a:ext cx="10881360" cy="914400"/>
+          </a:xfrm>
+          <a:prstGeom prst="rect">
+            <a:avLst/>
+          </a:prstGeom>
+          <a:noFill/>
+          <a:ln/>
+        </p:spPr>
+        <p:txBody>
+          <a:bodyPr wrap="square" lIns="0" tIns="0" rIns="0" bIns="0" rtlCol="0" anchor="t"/>
           <a:lstStyle/>
           <a:p>
             <a:pPr indent="0" marL="0">
@@ -3544,17 +3544,17 @@
         </p:nvSpPr>
         <p:spPr>
           <a:xfrm>
-            <a:off x="640080" y="640080"/>
-            <a:ext cx="10881360" cy="566928"/>
-          </a:xfrm>
-          <a:prstGeom prst="rect">
-            <a:avLst/>
-          </a:prstGeom>
-          <a:noFill/>
-          <a:ln/>
-        </p:spPr>
-        <p:txBody>
-          <a:bodyPr wrap="square" rtlCol="0" anchor="ctr"/>
+            <a:off x="640080" y="658368"/>
+            <a:ext cx="10881360" cy="914400"/>
+          </a:xfrm>
+          <a:prstGeom prst="rect">
+            <a:avLst/>
+          </a:prstGeom>
+          <a:noFill/>
+          <a:ln/>
+        </p:spPr>
+        <p:txBody>
+          <a:bodyPr wrap="square" lIns="0" tIns="0" rIns="0" bIns="0" rtlCol="0" anchor="t"/>
           <a:lstStyle/>
           <a:p>
             <a:pPr indent="0" marL="0">
@@ -4548,17 +4548,17 @@
         </p:nvSpPr>
         <p:spPr>
           <a:xfrm>
-            <a:off x="640080" y="640080"/>
-            <a:ext cx="10881360" cy="566928"/>
-          </a:xfrm>
-          <a:prstGeom prst="rect">
-            <a:avLst/>
-          </a:prstGeom>
-          <a:noFill/>
-          <a:ln/>
-        </p:spPr>
-        <p:txBody>
-          <a:bodyPr wrap="square" rtlCol="0" anchor="ctr"/>
+            <a:off x="640080" y="658368"/>
+            <a:ext cx="10881360" cy="914400"/>
+          </a:xfrm>
+          <a:prstGeom prst="rect">
+            <a:avLst/>
+          </a:prstGeom>
+          <a:noFill/>
+          <a:ln/>
+        </p:spPr>
+        <p:txBody>
+          <a:bodyPr wrap="square" lIns="0" tIns="0" rIns="0" bIns="0" rtlCol="0" anchor="t"/>
           <a:lstStyle/>
           <a:p>
             <a:pPr indent="0" marL="0">
@@ -6029,17 +6029,17 @@
         </p:nvSpPr>
         <p:spPr>
           <a:xfrm>
-            <a:off x="640080" y="640080"/>
-            <a:ext cx="10881360" cy="566928"/>
-          </a:xfrm>
-          <a:prstGeom prst="rect">
-            <a:avLst/>
-          </a:prstGeom>
-          <a:noFill/>
-          <a:ln/>
-        </p:spPr>
-        <p:txBody>
-          <a:bodyPr wrap="square" rtlCol="0" anchor="ctr"/>
+            <a:off x="640080" y="658368"/>
+            <a:ext cx="10881360" cy="914400"/>
+          </a:xfrm>
+          <a:prstGeom prst="rect">
+            <a:avLst/>
+          </a:prstGeom>
+          <a:noFill/>
+          <a:ln/>
+        </p:spPr>
+        <p:txBody>
+          <a:bodyPr wrap="square" lIns="0" tIns="0" rIns="0" bIns="0" rtlCol="0" anchor="t"/>
           <a:lstStyle/>
           <a:p>
             <a:pPr indent="0" marL="0">
@@ -6173,7 +6173,7 @@
         </p:nvSpPr>
         <p:spPr>
           <a:xfrm>
-            <a:off x="640080" y="2157984"/>
+            <a:off x="640080" y="2112264"/>
             <a:ext cx="10881360" cy="530352"/>
           </a:xfrm>
           <a:prstGeom prst="roundRect">
@@ -6200,7 +6200,7 @@
         </p:nvSpPr>
         <p:spPr>
           <a:xfrm>
-            <a:off x="896112" y="2194560"/>
+            <a:off x="896112" y="2148840"/>
             <a:ext cx="3657600" cy="457200"/>
           </a:xfrm>
           <a:prstGeom prst="rect">
@@ -6239,7 +6239,7 @@
         </p:nvSpPr>
         <p:spPr>
           <a:xfrm>
-            <a:off x="4663440" y="2194560"/>
+            <a:off x="4663440" y="2148840"/>
             <a:ext cx="6583680" cy="457200"/>
           </a:xfrm>
           <a:prstGeom prst="rect">
@@ -6278,7 +6278,7 @@
         </p:nvSpPr>
         <p:spPr>
           <a:xfrm>
-            <a:off x="640080" y="2761488"/>
+            <a:off x="640080" y="2670048"/>
             <a:ext cx="10881360" cy="530352"/>
           </a:xfrm>
           <a:prstGeom prst="roundRect">
@@ -6305,7 +6305,7 @@
         </p:nvSpPr>
         <p:spPr>
           <a:xfrm>
-            <a:off x="896112" y="2798064"/>
+            <a:off x="896112" y="2706624"/>
             <a:ext cx="3657600" cy="457200"/>
           </a:xfrm>
           <a:prstGeom prst="rect">
@@ -6344,7 +6344,7 @@
         </p:nvSpPr>
         <p:spPr>
           <a:xfrm>
-            <a:off x="4663440" y="2798064"/>
+            <a:off x="4663440" y="2706624"/>
             <a:ext cx="6583680" cy="457200"/>
           </a:xfrm>
           <a:prstGeom prst="rect">
@@ -6383,7 +6383,7 @@
         </p:nvSpPr>
         <p:spPr>
           <a:xfrm>
-            <a:off x="640080" y="3364992"/>
+            <a:off x="640080" y="3227832"/>
             <a:ext cx="10881360" cy="530352"/>
           </a:xfrm>
           <a:prstGeom prst="roundRect">
@@ -6410,7 +6410,7 @@
         </p:nvSpPr>
         <p:spPr>
           <a:xfrm>
-            <a:off x="896112" y="3401568"/>
+            <a:off x="896112" y="3264408"/>
             <a:ext cx="3657600" cy="457200"/>
           </a:xfrm>
           <a:prstGeom prst="rect">
@@ -6449,7 +6449,7 @@
         </p:nvSpPr>
         <p:spPr>
           <a:xfrm>
-            <a:off x="4663440" y="3401568"/>
+            <a:off x="4663440" y="3264408"/>
             <a:ext cx="6583680" cy="457200"/>
           </a:xfrm>
           <a:prstGeom prst="rect">
@@ -6488,7 +6488,7 @@
         </p:nvSpPr>
         <p:spPr>
           <a:xfrm>
-            <a:off x="640080" y="3968496"/>
+            <a:off x="640080" y="3785616"/>
             <a:ext cx="10881360" cy="530352"/>
           </a:xfrm>
           <a:prstGeom prst="roundRect">
@@ -6515,7 +6515,7 @@
         </p:nvSpPr>
         <p:spPr>
           <a:xfrm>
-            <a:off x="896112" y="4005072"/>
+            <a:off x="896112" y="3822192"/>
             <a:ext cx="3657600" cy="457200"/>
           </a:xfrm>
           <a:prstGeom prst="rect">
@@ -6554,7 +6554,7 @@
         </p:nvSpPr>
         <p:spPr>
           <a:xfrm>
-            <a:off x="4663440" y="4005072"/>
+            <a:off x="4663440" y="3822192"/>
             <a:ext cx="6583680" cy="457200"/>
           </a:xfrm>
           <a:prstGeom prst="rect">
@@ -6593,7 +6593,7 @@
         </p:nvSpPr>
         <p:spPr>
           <a:xfrm>
-            <a:off x="640080" y="4572000"/>
+            <a:off x="640080" y="4343400"/>
             <a:ext cx="10881360" cy="530352"/>
           </a:xfrm>
           <a:prstGeom prst="roundRect">
@@ -6620,7 +6620,7 @@
         </p:nvSpPr>
         <p:spPr>
           <a:xfrm>
-            <a:off x="896112" y="4608576"/>
+            <a:off x="896112" y="4379976"/>
             <a:ext cx="3657600" cy="457200"/>
           </a:xfrm>
           <a:prstGeom prst="rect">
@@ -6659,7 +6659,7 @@
         </p:nvSpPr>
         <p:spPr>
           <a:xfrm>
-            <a:off x="4663440" y="4608576"/>
+            <a:off x="4663440" y="4379976"/>
             <a:ext cx="6583680" cy="457200"/>
           </a:xfrm>
           <a:prstGeom prst="rect">
@@ -6698,7 +6698,7 @@
         </p:nvSpPr>
         <p:spPr>
           <a:xfrm>
-            <a:off x="640080" y="5175504"/>
+            <a:off x="640080" y="4901184"/>
             <a:ext cx="10881360" cy="530352"/>
           </a:xfrm>
           <a:prstGeom prst="roundRect">
@@ -6725,7 +6725,7 @@
         </p:nvSpPr>
         <p:spPr>
           <a:xfrm>
-            <a:off x="896112" y="5212080"/>
+            <a:off x="896112" y="4937760"/>
             <a:ext cx="3657600" cy="457200"/>
           </a:xfrm>
           <a:prstGeom prst="rect">
@@ -6764,7 +6764,7 @@
         </p:nvSpPr>
         <p:spPr>
           <a:xfrm>
-            <a:off x="4663440" y="5212080"/>
+            <a:off x="4663440" y="4937760"/>
             <a:ext cx="6583680" cy="457200"/>
           </a:xfrm>
           <a:prstGeom prst="rect">
@@ -6803,7 +6803,7 @@
         </p:nvSpPr>
         <p:spPr>
           <a:xfrm>
-            <a:off x="640080" y="5779008"/>
+            <a:off x="640080" y="5458968"/>
             <a:ext cx="10881360" cy="530352"/>
           </a:xfrm>
           <a:prstGeom prst="roundRect">
@@ -6830,7 +6830,7 @@
         </p:nvSpPr>
         <p:spPr>
           <a:xfrm>
-            <a:off x="896112" y="5815584"/>
+            <a:off x="896112" y="5495544"/>
             <a:ext cx="3657600" cy="457200"/>
           </a:xfrm>
           <a:prstGeom prst="rect">
@@ -6869,7 +6869,7 @@
         </p:nvSpPr>
         <p:spPr>
           <a:xfrm>
-            <a:off x="4663440" y="5815584"/>
+            <a:off x="4663440" y="5495544"/>
             <a:ext cx="6583680" cy="457200"/>
           </a:xfrm>
           <a:prstGeom prst="rect">
@@ -6908,8 +6908,8 @@
         </p:nvSpPr>
         <p:spPr>
           <a:xfrm>
-            <a:off x="640080" y="6263640"/>
-            <a:ext cx="10881360" cy="320040"/>
+            <a:off x="640080" y="6108192"/>
+            <a:ext cx="10881360" cy="292608"/>
           </a:xfrm>
           <a:prstGeom prst="rect">
             <a:avLst/>
@@ -7096,17 +7096,17 @@
         </p:nvSpPr>
         <p:spPr>
           <a:xfrm>
-            <a:off x="640080" y="640080"/>
-            <a:ext cx="10881360" cy="566928"/>
-          </a:xfrm>
-          <a:prstGeom prst="rect">
-            <a:avLst/>
-          </a:prstGeom>
-          <a:noFill/>
-          <a:ln/>
-        </p:spPr>
-        <p:txBody>
-          <a:bodyPr wrap="square" rtlCol="0" anchor="ctr"/>
+            <a:off x="640080" y="658368"/>
+            <a:ext cx="10881360" cy="914400"/>
+          </a:xfrm>
+          <a:prstGeom prst="rect">
+            <a:avLst/>
+          </a:prstGeom>
+          <a:noFill/>
+          <a:ln/>
+        </p:spPr>
+        <p:txBody>
+          <a:bodyPr wrap="square" lIns="0" tIns="0" rIns="0" bIns="0" rtlCol="0" anchor="t"/>
           <a:lstStyle/>
           <a:p>
             <a:pPr indent="0" marL="0">
@@ -7121,7 +7121,7 @@
                 <a:ea typeface="Cambria" pitchFamily="34" charset="-122"/>
                 <a:cs typeface="Cambria" pitchFamily="34" charset="-120"/>
               </a:rPr>
-              <a:t>Families are signing leases without knowing their real pay</a:t>
+              <a:t>Signing leases without knowing the real pay</a:t>
             </a:r>
             <a:endParaRPr lang="en-US" sz="3200" dirty="0"/>
           </a:p>
@@ -7638,17 +7638,17 @@
         </p:nvSpPr>
         <p:spPr>
           <a:xfrm>
-            <a:off x="640080" y="640080"/>
-            <a:ext cx="10881360" cy="566928"/>
-          </a:xfrm>
-          <a:prstGeom prst="rect">
-            <a:avLst/>
-          </a:prstGeom>
-          <a:noFill/>
-          <a:ln/>
-        </p:spPr>
-        <p:txBody>
-          <a:bodyPr wrap="square" rtlCol="0" anchor="ctr"/>
+            <a:off x="640080" y="658368"/>
+            <a:ext cx="10881360" cy="914400"/>
+          </a:xfrm>
+          <a:prstGeom prst="rect">
+            <a:avLst/>
+          </a:prstGeom>
+          <a:noFill/>
+          <a:ln/>
+        </p:spPr>
+        <p:txBody>
+          <a:bodyPr wrap="square" lIns="0" tIns="0" rIns="0" bIns="0" rtlCol="0" anchor="t"/>
           <a:lstStyle/>
           <a:p>
             <a:pPr indent="0" marL="0">
@@ -8587,17 +8587,17 @@
         </p:nvSpPr>
         <p:spPr>
           <a:xfrm>
-            <a:off x="640080" y="640080"/>
-            <a:ext cx="10881360" cy="566928"/>
-          </a:xfrm>
-          <a:prstGeom prst="rect">
-            <a:avLst/>
-          </a:prstGeom>
-          <a:noFill/>
-          <a:ln/>
-        </p:spPr>
-        <p:txBody>
-          <a:bodyPr wrap="square" rtlCol="0" anchor="ctr"/>
+            <a:off x="640080" y="658368"/>
+            <a:ext cx="10881360" cy="914400"/>
+          </a:xfrm>
+          <a:prstGeom prst="rect">
+            <a:avLst/>
+          </a:prstGeom>
+          <a:noFill/>
+          <a:ln/>
+        </p:spPr>
+        <p:txBody>
+          <a:bodyPr wrap="square" lIns="0" tIns="0" rIns="0" bIns="0" rtlCol="0" anchor="t"/>
           <a:lstStyle/>
           <a:p>
             <a:pPr indent="0" marL="0">
@@ -8790,7 +8790,7 @@
         </p:nvSpPr>
         <p:spPr>
           <a:xfrm>
-            <a:off x="640080" y="2788920"/>
+            <a:off x="640080" y="2724912"/>
             <a:ext cx="10881360" cy="1005840"/>
           </a:xfrm>
           <a:prstGeom prst="roundRect">
@@ -8817,7 +8817,7 @@
         </p:nvSpPr>
         <p:spPr>
           <a:xfrm>
-            <a:off x="896112" y="3044952"/>
+            <a:off x="896112" y="2980944"/>
             <a:ext cx="502920" cy="502920"/>
           </a:xfrm>
           <a:prstGeom prst="ellipse">
@@ -8837,7 +8837,7 @@
         </p:nvSpPr>
         <p:spPr>
           <a:xfrm>
-            <a:off x="896112" y="3044952"/>
+            <a:off x="896112" y="2980944"/>
             <a:ext cx="502920" cy="502920"/>
           </a:xfrm>
           <a:prstGeom prst="rect">
@@ -8876,7 +8876,7 @@
         </p:nvSpPr>
         <p:spPr>
           <a:xfrm>
-            <a:off x="1600200" y="2935224"/>
+            <a:off x="1600200" y="2871216"/>
             <a:ext cx="3291840" cy="365760"/>
           </a:xfrm>
           <a:prstGeom prst="rect">
@@ -8915,7 +8915,7 @@
         </p:nvSpPr>
         <p:spPr>
           <a:xfrm>
-            <a:off x="4983480" y="2935224"/>
+            <a:off x="4983480" y="2871216"/>
             <a:ext cx="6309360" cy="731520"/>
           </a:xfrm>
           <a:prstGeom prst="rect">
@@ -8954,7 +8954,7 @@
         </p:nvSpPr>
         <p:spPr>
           <a:xfrm>
-            <a:off x="640080" y="3931920"/>
+            <a:off x="640080" y="3803904"/>
             <a:ext cx="10881360" cy="1005840"/>
           </a:xfrm>
           <a:prstGeom prst="roundRect">
@@ -8981,7 +8981,7 @@
         </p:nvSpPr>
         <p:spPr>
           <a:xfrm>
-            <a:off x="896112" y="4187952"/>
+            <a:off x="896112" y="4059936"/>
             <a:ext cx="502920" cy="502920"/>
           </a:xfrm>
           <a:prstGeom prst="ellipse">
@@ -9001,7 +9001,7 @@
         </p:nvSpPr>
         <p:spPr>
           <a:xfrm>
-            <a:off x="896112" y="4187952"/>
+            <a:off x="896112" y="4059936"/>
             <a:ext cx="502920" cy="502920"/>
           </a:xfrm>
           <a:prstGeom prst="rect">
@@ -9040,7 +9040,7 @@
         </p:nvSpPr>
         <p:spPr>
           <a:xfrm>
-            <a:off x="1600200" y="4078224"/>
+            <a:off x="1600200" y="3950208"/>
             <a:ext cx="3291840" cy="365760"/>
           </a:xfrm>
           <a:prstGeom prst="rect">
@@ -9079,7 +9079,7 @@
         </p:nvSpPr>
         <p:spPr>
           <a:xfrm>
-            <a:off x="4983480" y="4078224"/>
+            <a:off x="4983480" y="3950208"/>
             <a:ext cx="6309360" cy="731520"/>
           </a:xfrm>
           <a:prstGeom prst="rect">
@@ -9118,7 +9118,7 @@
         </p:nvSpPr>
         <p:spPr>
           <a:xfrm>
-            <a:off x="640080" y="5074920"/>
+            <a:off x="640080" y="4882896"/>
             <a:ext cx="10881360" cy="1005840"/>
           </a:xfrm>
           <a:prstGeom prst="roundRect">
@@ -9145,7 +9145,7 @@
         </p:nvSpPr>
         <p:spPr>
           <a:xfrm>
-            <a:off x="896112" y="5330952"/>
+            <a:off x="896112" y="5138928"/>
             <a:ext cx="502920" cy="502920"/>
           </a:xfrm>
           <a:prstGeom prst="ellipse">
@@ -9165,7 +9165,7 @@
         </p:nvSpPr>
         <p:spPr>
           <a:xfrm>
-            <a:off x="896112" y="5330952"/>
+            <a:off x="896112" y="5138928"/>
             <a:ext cx="502920" cy="502920"/>
           </a:xfrm>
           <a:prstGeom prst="rect">
@@ -9204,7 +9204,7 @@
         </p:nvSpPr>
         <p:spPr>
           <a:xfrm>
-            <a:off x="1600200" y="5221224"/>
+            <a:off x="1600200" y="5029200"/>
             <a:ext cx="3291840" cy="365760"/>
           </a:xfrm>
           <a:prstGeom prst="rect">
@@ -9243,7 +9243,7 @@
         </p:nvSpPr>
         <p:spPr>
           <a:xfrm>
-            <a:off x="4983480" y="5221224"/>
+            <a:off x="4983480" y="5029200"/>
             <a:ext cx="6309360" cy="731520"/>
           </a:xfrm>
           <a:prstGeom prst="rect">
@@ -9282,7 +9282,7 @@
         </p:nvSpPr>
         <p:spPr>
           <a:xfrm>
-            <a:off x="640080" y="5943600"/>
+            <a:off x="640080" y="6035040"/>
             <a:ext cx="10881360" cy="365760"/>
           </a:xfrm>
           <a:prstGeom prst="rect">
@@ -9470,17 +9470,17 @@
         </p:nvSpPr>
         <p:spPr>
           <a:xfrm>
-            <a:off x="640080" y="640080"/>
-            <a:ext cx="10881360" cy="566928"/>
-          </a:xfrm>
-          <a:prstGeom prst="rect">
-            <a:avLst/>
-          </a:prstGeom>
-          <a:noFill/>
-          <a:ln/>
-        </p:spPr>
-        <p:txBody>
-          <a:bodyPr wrap="square" rtlCol="0" anchor="ctr"/>
+            <a:off x="640080" y="658368"/>
+            <a:ext cx="10881360" cy="914400"/>
+          </a:xfrm>
+          <a:prstGeom prst="rect">
+            <a:avLst/>
+          </a:prstGeom>
+          <a:noFill/>
+          <a:ln/>
+        </p:spPr>
+        <p:txBody>
+          <a:bodyPr wrap="square" lIns="0" tIns="0" rIns="0" bIns="0" rtlCol="0" anchor="t"/>
           <a:lstStyle/>
           <a:p>
             <a:pPr indent="0" marL="0">
@@ -10519,17 +10519,17 @@
         </p:nvSpPr>
         <p:spPr>
           <a:xfrm>
-            <a:off x="640080" y="640080"/>
-            <a:ext cx="10881360" cy="566928"/>
-          </a:xfrm>
-          <a:prstGeom prst="rect">
-            <a:avLst/>
-          </a:prstGeom>
-          <a:noFill/>
-          <a:ln/>
-        </p:spPr>
-        <p:txBody>
-          <a:bodyPr wrap="square" rtlCol="0" anchor="ctr"/>
+            <a:off x="640080" y="658368"/>
+            <a:ext cx="10881360" cy="914400"/>
+          </a:xfrm>
+          <a:prstGeom prst="rect">
+            <a:avLst/>
+          </a:prstGeom>
+          <a:noFill/>
+          <a:ln/>
+        </p:spPr>
+        <p:txBody>
+          <a:bodyPr wrap="square" lIns="0" tIns="0" rIns="0" bIns="0" rtlCol="0" anchor="t"/>
           <a:lstStyle/>
           <a:p>
             <a:pPr indent="0" marL="0">
@@ -12131,17 +12131,17 @@
         </p:nvSpPr>
         <p:spPr>
           <a:xfrm>
-            <a:off x="640080" y="640080"/>
-            <a:ext cx="10881360" cy="566928"/>
-          </a:xfrm>
-          <a:prstGeom prst="rect">
-            <a:avLst/>
-          </a:prstGeom>
-          <a:noFill/>
-          <a:ln/>
-        </p:spPr>
-        <p:txBody>
-          <a:bodyPr wrap="square" rtlCol="0" anchor="ctr"/>
+            <a:off x="640080" y="658368"/>
+            <a:ext cx="10881360" cy="914400"/>
+          </a:xfrm>
+          <a:prstGeom prst="rect">
+            <a:avLst/>
+          </a:prstGeom>
+          <a:noFill/>
+          <a:ln/>
+        </p:spPr>
+        <p:txBody>
+          <a:bodyPr wrap="square" lIns="0" tIns="0" rIns="0" bIns="0" rtlCol="0" anchor="t"/>
           <a:lstStyle/>
           <a:p>
             <a:pPr indent="0" marL="0">
@@ -13138,17 +13138,17 @@
         </p:nvSpPr>
         <p:spPr>
           <a:xfrm>
-            <a:off x="640080" y="640080"/>
-            <a:ext cx="10881360" cy="566928"/>
-          </a:xfrm>
-          <a:prstGeom prst="rect">
-            <a:avLst/>
-          </a:prstGeom>
-          <a:noFill/>
-          <a:ln/>
-        </p:spPr>
-        <p:txBody>
-          <a:bodyPr wrap="square" rtlCol="0" anchor="ctr"/>
+            <a:off x="640080" y="658368"/>
+            <a:ext cx="10881360" cy="914400"/>
+          </a:xfrm>
+          <a:prstGeom prst="rect">
+            <a:avLst/>
+          </a:prstGeom>
+          <a:noFill/>
+          <a:ln/>
+        </p:spPr>
+        <p:txBody>
+          <a:bodyPr wrap="square" lIns="0" tIns="0" rIns="0" bIns="0" rtlCol="0" anchor="t"/>
           <a:lstStyle/>
           <a:p>
             <a:pPr indent="0" marL="0">
@@ -14563,17 +14563,17 @@
         </p:nvSpPr>
         <p:spPr>
           <a:xfrm>
-            <a:off x="640080" y="640080"/>
-            <a:ext cx="10881360" cy="566928"/>
-          </a:xfrm>
-          <a:prstGeom prst="rect">
-            <a:avLst/>
-          </a:prstGeom>
-          <a:noFill/>
-          <a:ln/>
-        </p:spPr>
-        <p:txBody>
-          <a:bodyPr wrap="square" rtlCol="0" anchor="ctr"/>
+            <a:off x="640080" y="658368"/>
+            <a:ext cx="10881360" cy="914400"/>
+          </a:xfrm>
+          <a:prstGeom prst="rect">
+            <a:avLst/>
+          </a:prstGeom>
+          <a:noFill/>
+          <a:ln/>
+        </p:spPr>
+        <p:txBody>
+          <a:bodyPr wrap="square" lIns="0" tIns="0" rIns="0" bIns="0" rtlCol="0" anchor="t"/>
           <a:lstStyle/>
           <a:p>
             <a:pPr indent="0" marL="0">

</xml_diff>

<commit_message>
﻿Source the off-base housing statistic on the deck
The 66% figure opening the deck had no attribution. Verified against Blue Star
Families own Military Family Lifestyle Survey and the Bipartisan Policy Center,
both of which put it at roughly two-thirds of active-duty families relying on
the civilian housing market. Attribution now appears under the claim.
</commit_message>
<xml_diff>
--- a/Military-Pay-Estimator-Guide.pptx
+++ b/Military-Pay-Estimator-Guide.pptx
@@ -7451,7 +7451,7 @@
         <p:spPr>
           <a:xfrm>
             <a:off x="640080" y="5532120"/>
-            <a:ext cx="10881360" cy="457200"/>
+            <a:ext cx="10881360" cy="365760"/>
           </a:xfrm>
           <a:prstGeom prst="rect">
             <a:avLst/>
@@ -7484,6 +7484,45 @@
       <p:sp>
         <p:nvSpPr>
           <p:cNvPr id="14" name="Text 12"/>
+          <p:cNvSpPr/>
+          <p:nvPr/>
+        </p:nvSpPr>
+        <p:spPr>
+          <a:xfrm>
+            <a:off x="640080" y="5897880"/>
+            <a:ext cx="10881360" cy="274320"/>
+          </a:xfrm>
+          <a:prstGeom prst="rect">
+            <a:avLst/>
+          </a:prstGeom>
+          <a:noFill/>
+          <a:ln/>
+        </p:spPr>
+        <p:txBody>
+          <a:bodyPr wrap="square" rtlCol="0" anchor="ctr"/>
+          <a:lstStyle/>
+          <a:p>
+            <a:pPr indent="0" marL="0">
+              <a:buNone/>
+            </a:pPr>
+            <a:r>
+              <a:rPr lang="en-US" sz="950" dirty="0">
+                <a:solidFill>
+                  <a:srgbClr val="5B6B7B"/>
+                </a:solidFill>
+                <a:latin typeface="Calibri" pitchFamily="34" charset="0"/>
+                <a:ea typeface="Calibri" pitchFamily="34" charset="-122"/>
+                <a:cs typeface="Calibri" pitchFamily="34" charset="-120"/>
+              </a:rPr>
+              <a:t>Roughly two-thirds of active-duty families rely on the civilian housing market (Blue Star Families Military Family Lifestyle Survey; Bipartisan Policy Center).</a:t>
+            </a:r>
+            <a:endParaRPr lang="en-US" sz="950" dirty="0"/>
+          </a:p>
+        </p:txBody>
+      </p:sp>
+      <p:sp>
+        <p:nvSpPr>
+          <p:cNvPr id="15" name="Text 13"/>
           <p:cNvSpPr/>
           <p:nvPr/>
         </p:nvSpPr>
@@ -7522,7 +7561,7 @@
       </p:sp>
       <p:sp>
         <p:nvSpPr>
-          <p:cNvPr id="15" name="Text 13"/>
+          <p:cNvPr id="16" name="Text 14"/>
           <p:cNvSpPr/>
           <p:nvPr/>
         </p:nvSpPr>

</xml_diff>